<commit_message>
Align pitch deck with submission rubric
</commit_message>
<xml_diff>
--- a/Vishwajeet_Kumar_SentinelGate_Pitch_Deck.pptx
+++ b/Vishwajeet_Kumar_SentinelGate_Pitch_Deck.pptx
@@ -3142,262 +3142,231 @@
           </a:p>
         </p:txBody>
       </p:sp>
-      <p:pic>
-        <p:nvPicPr>
-          <p:cNvPr id="3" name="Picture 2" descr="01_title.png"/>
-          <p:cNvPicPr>
-            <a:picLocks noChangeAspect="1"/>
-          </p:cNvPicPr>
-          <p:nvPr/>
-        </p:nvPicPr>
-        <p:blipFill>
-          <a:blip r:embed="rId2"/>
-          <a:stretch>
-            <a:fillRect/>
-          </a:stretch>
-        </p:blipFill>
-        <p:spPr>
-          <a:xfrm>
-            <a:off x="0" y="0"/>
-            <a:ext cx="12191695" cy="6858000"/>
-          </a:xfrm>
-          <a:prstGeom prst="rect">
-            <a:avLst/>
-          </a:prstGeom>
-        </p:spPr>
-      </p:pic>
-      <p:sp>
-        <p:nvSpPr>
-          <p:cNvPr id="4" name="Rectangle 3"/>
+      <p:sp>
+        <p:nvSpPr>
+          <p:cNvPr id="3" name="TextBox 2"/>
+          <p:cNvSpPr txBox="1"/>
+          <p:nvPr/>
+        </p:nvSpPr>
+        <p:spPr>
+          <a:xfrm>
+            <a:off x="594360" y="438912"/>
+            <a:ext cx="5669280" cy="274320"/>
+          </a:xfrm>
+          <a:prstGeom prst="rect">
+            <a:avLst/>
+          </a:prstGeom>
+          <a:noFill/>
+        </p:spPr>
+        <p:txBody>
+          <a:bodyPr wrap="square" lIns="0" rIns="0" tIns="0" bIns="0" anchor="t">
+            <a:spAutoFit/>
+          </a:bodyPr>
+          <a:lstStyle/>
+          <a:p>
+            <a:pPr algn="l">
+              <a:defRPr sz="1200" b="1">
+                <a:solidFill>
+                  <a:srgbClr val="69E3AC"/>
+                </a:solidFill>
+                <a:latin typeface="Cascadia Mono"/>
+              </a:defRPr>
+            </a:pPr>
+            <a:r>
+              <a:t>ET AI HACKATHON: AGENTIC EDITION</a:t>
+            </a:r>
+          </a:p>
+        </p:txBody>
+      </p:sp>
+      <p:sp>
+        <p:nvSpPr>
+          <p:cNvPr id="4" name="TextBox 3"/>
+          <p:cNvSpPr txBox="1"/>
+          <p:nvPr/>
+        </p:nvSpPr>
+        <p:spPr>
+          <a:xfrm>
+            <a:off x="594360" y="768096"/>
+            <a:ext cx="3657600" cy="228600"/>
+          </a:xfrm>
+          <a:prstGeom prst="rect">
+            <a:avLst/>
+          </a:prstGeom>
+          <a:noFill/>
+        </p:spPr>
+        <p:txBody>
+          <a:bodyPr wrap="square" lIns="0" rIns="0" tIns="0" bIns="0" anchor="t">
+            <a:spAutoFit/>
+          </a:bodyPr>
+          <a:lstStyle/>
+          <a:p>
+            <a:pPr algn="l">
+              <a:defRPr sz="1200" b="0">
+                <a:solidFill>
+                  <a:srgbClr val="8CA39F"/>
+                </a:solidFill>
+                <a:latin typeface="Aptos"/>
+              </a:defRPr>
+            </a:pPr>
+            <a:r>
+              <a:t>Presented by Accenture</a:t>
+            </a:r>
+          </a:p>
+        </p:txBody>
+      </p:sp>
+      <p:sp>
+        <p:nvSpPr>
+          <p:cNvPr id="5" name="TextBox 4"/>
+          <p:cNvSpPr txBox="1"/>
+          <p:nvPr/>
+        </p:nvSpPr>
+        <p:spPr>
+          <a:xfrm>
+            <a:off x="594360" y="1261872"/>
+            <a:ext cx="2926080" cy="182880"/>
+          </a:xfrm>
+          <a:prstGeom prst="rect">
+            <a:avLst/>
+          </a:prstGeom>
+          <a:noFill/>
+        </p:spPr>
+        <p:txBody>
+          <a:bodyPr wrap="square" lIns="0" rIns="0" tIns="0" bIns="0" anchor="t">
+            <a:spAutoFit/>
+          </a:bodyPr>
+          <a:lstStyle/>
+          <a:p>
+            <a:pPr algn="l">
+              <a:defRPr sz="1000" b="1">
+                <a:solidFill>
+                  <a:srgbClr val="6FB9FF"/>
+                </a:solidFill>
+                <a:latin typeface="Cascadia Mono"/>
+              </a:defRPr>
+            </a:pPr>
+            <a:r>
+              <a:t>TEAM INTRODUCTION</a:t>
+            </a:r>
+          </a:p>
+        </p:txBody>
+      </p:sp>
+      <p:sp>
+        <p:nvSpPr>
+          <p:cNvPr id="6" name="TextBox 5"/>
+          <p:cNvSpPr txBox="1"/>
+          <p:nvPr/>
+        </p:nvSpPr>
+        <p:spPr>
+          <a:xfrm>
+            <a:off x="594360" y="1600200"/>
+            <a:ext cx="5394960" cy="594360"/>
+          </a:xfrm>
+          <a:prstGeom prst="rect">
+            <a:avLst/>
+          </a:prstGeom>
+          <a:noFill/>
+        </p:spPr>
+        <p:txBody>
+          <a:bodyPr wrap="square" lIns="0" rIns="0" tIns="0" bIns="0" anchor="t">
+            <a:spAutoFit/>
+          </a:bodyPr>
+          <a:lstStyle/>
+          <a:p>
+            <a:pPr algn="l">
+              <a:defRPr sz="3800" b="1">
+                <a:solidFill>
+                  <a:srgbClr val="EDF5F1"/>
+                </a:solidFill>
+                <a:latin typeface="Aptos Display"/>
+              </a:defRPr>
+            </a:pPr>
+            <a:r>
+              <a:t>SentinelGate</a:t>
+            </a:r>
+          </a:p>
+        </p:txBody>
+      </p:sp>
+      <p:sp>
+        <p:nvSpPr>
+          <p:cNvPr id="7" name="TextBox 6"/>
+          <p:cNvSpPr txBox="1"/>
+          <p:nvPr/>
+        </p:nvSpPr>
+        <p:spPr>
+          <a:xfrm>
+            <a:off x="594360" y="2240280"/>
+            <a:ext cx="5577840" cy="457200"/>
+          </a:xfrm>
+          <a:prstGeom prst="rect">
+            <a:avLst/>
+          </a:prstGeom>
+          <a:noFill/>
+        </p:spPr>
+        <p:txBody>
+          <a:bodyPr wrap="square" lIns="0" rIns="0" tIns="0" bIns="0" anchor="t">
+            <a:spAutoFit/>
+          </a:bodyPr>
+          <a:lstStyle/>
+          <a:p>
+            <a:pPr algn="l">
+              <a:defRPr sz="2300" b="1">
+                <a:solidFill>
+                  <a:srgbClr val="69E3AC"/>
+                </a:solidFill>
+                <a:latin typeface="Aptos"/>
+              </a:defRPr>
+            </a:pPr>
+            <a:r>
+              <a:t>Zero-Trust Prompt Injection Firewall</a:t>
+            </a:r>
+          </a:p>
+        </p:txBody>
+      </p:sp>
+      <p:sp>
+        <p:nvSpPr>
+          <p:cNvPr id="8" name="TextBox 7"/>
+          <p:cNvSpPr txBox="1"/>
+          <p:nvPr/>
+        </p:nvSpPr>
+        <p:spPr>
+          <a:xfrm>
+            <a:off x="594360" y="2889504"/>
+            <a:ext cx="4937760" cy="347472"/>
+          </a:xfrm>
+          <a:prstGeom prst="rect">
+            <a:avLst/>
+          </a:prstGeom>
+          <a:noFill/>
+        </p:spPr>
+        <p:txBody>
+          <a:bodyPr wrap="square" lIns="0" rIns="0" tIns="0" bIns="0" anchor="t">
+            <a:spAutoFit/>
+          </a:bodyPr>
+          <a:lstStyle/>
+          <a:p>
+            <a:pPr algn="l">
+              <a:defRPr sz="1900" b="0">
+                <a:solidFill>
+                  <a:srgbClr val="EDF5F1"/>
+                </a:solidFill>
+                <a:latin typeface="Aptos"/>
+              </a:defRPr>
+            </a:pPr>
+            <a:r>
+              <a:t>Inspect before the agent can act.</a:t>
+            </a:r>
+          </a:p>
+        </p:txBody>
+      </p:sp>
+      <p:sp>
+        <p:nvSpPr>
+          <p:cNvPr id="9" name="Rounded Rectangle 8"/>
           <p:cNvSpPr/>
           <p:nvPr/>
         </p:nvSpPr>
         <p:spPr>
           <a:xfrm>
-            <a:off x="0" y="0"/>
-            <a:ext cx="6766560" cy="6858000"/>
-          </a:xfrm>
-          <a:prstGeom prst="rect">
-            <a:avLst/>
-          </a:prstGeom>
-          <a:solidFill>
-            <a:srgbClr val="071317"/>
-          </a:solidFill>
-          <a:ln>
-            <a:noFill/>
-          </a:ln>
-        </p:spPr>
-        <p:style>
-          <a:lnRef idx="1">
-            <a:schemeClr val="accent1"/>
-          </a:lnRef>
-          <a:fillRef idx="3">
-            <a:schemeClr val="accent1"/>
-          </a:fillRef>
-          <a:effectRef idx="2">
-            <a:schemeClr val="accent1"/>
-          </a:effectRef>
-          <a:fontRef idx="minor">
-            <a:schemeClr val="lt1"/>
-          </a:fontRef>
-        </p:style>
-        <p:txBody>
-          <a:bodyPr rtlCol="0" anchor="ctr"/>
-          <a:lstStyle/>
-          <a:p>
-            <a:pPr algn="ctr"/>
-          </a:p>
-        </p:txBody>
-      </p:sp>
-      <p:sp>
-        <p:nvSpPr>
-          <p:cNvPr id="5" name="TextBox 4"/>
-          <p:cNvSpPr txBox="1"/>
-          <p:nvPr/>
-        </p:nvSpPr>
-        <p:spPr>
-          <a:xfrm>
-            <a:off x="594360" y="502920"/>
-            <a:ext cx="5669280" cy="274320"/>
-          </a:xfrm>
-          <a:prstGeom prst="rect">
-            <a:avLst/>
-          </a:prstGeom>
-          <a:noFill/>
-        </p:spPr>
-        <p:txBody>
-          <a:bodyPr wrap="square" lIns="0" rIns="0" tIns="0" bIns="0" anchor="t">
-            <a:spAutoFit/>
-          </a:bodyPr>
-          <a:lstStyle/>
-          <a:p>
-            <a:pPr algn="l">
-              <a:defRPr sz="1200" b="1">
-                <a:solidFill>
-                  <a:srgbClr val="69E3AC"/>
-                </a:solidFill>
-                <a:latin typeface="Cascadia Mono"/>
-              </a:defRPr>
-            </a:pPr>
-            <a:r>
-              <a:t>ET AI HACKATHON: AGENTIC EDITION</a:t>
-            </a:r>
-          </a:p>
-        </p:txBody>
-      </p:sp>
-      <p:sp>
-        <p:nvSpPr>
-          <p:cNvPr id="6" name="TextBox 5"/>
-          <p:cNvSpPr txBox="1"/>
-          <p:nvPr/>
-        </p:nvSpPr>
-        <p:spPr>
-          <a:xfrm>
-            <a:off x="594360" y="841248"/>
-            <a:ext cx="3657600" cy="228600"/>
-          </a:xfrm>
-          <a:prstGeom prst="rect">
-            <a:avLst/>
-          </a:prstGeom>
-          <a:noFill/>
-        </p:spPr>
-        <p:txBody>
-          <a:bodyPr wrap="square" lIns="0" rIns="0" tIns="0" bIns="0" anchor="t">
-            <a:spAutoFit/>
-          </a:bodyPr>
-          <a:lstStyle/>
-          <a:p>
-            <a:pPr algn="l">
-              <a:defRPr sz="1200" b="0">
-                <a:solidFill>
-                  <a:srgbClr val="8CA39F"/>
-                </a:solidFill>
-                <a:latin typeface="Aptos"/>
-              </a:defRPr>
-            </a:pPr>
-            <a:r>
-              <a:t>Presented by Accenture</a:t>
-            </a:r>
-          </a:p>
-        </p:txBody>
-      </p:sp>
-      <p:sp>
-        <p:nvSpPr>
-          <p:cNvPr id="7" name="TextBox 6"/>
-          <p:cNvSpPr txBox="1"/>
-          <p:nvPr/>
-        </p:nvSpPr>
-        <p:spPr>
-          <a:xfrm>
-            <a:off x="594360" y="1444752"/>
-            <a:ext cx="5394960" cy="594360"/>
-          </a:xfrm>
-          <a:prstGeom prst="rect">
-            <a:avLst/>
-          </a:prstGeom>
-          <a:noFill/>
-        </p:spPr>
-        <p:txBody>
-          <a:bodyPr wrap="square" lIns="0" rIns="0" tIns="0" bIns="0" anchor="t">
-            <a:spAutoFit/>
-          </a:bodyPr>
-          <a:lstStyle/>
-          <a:p>
-            <a:pPr algn="l">
-              <a:defRPr sz="3800" b="1">
-                <a:solidFill>
-                  <a:srgbClr val="EDF5F1"/>
-                </a:solidFill>
-                <a:latin typeface="Aptos Display"/>
-              </a:defRPr>
-            </a:pPr>
-            <a:r>
-              <a:t>SentinelGate</a:t>
-            </a:r>
-          </a:p>
-        </p:txBody>
-      </p:sp>
-      <p:sp>
-        <p:nvSpPr>
-          <p:cNvPr id="8" name="TextBox 7"/>
-          <p:cNvSpPr txBox="1"/>
-          <p:nvPr/>
-        </p:nvSpPr>
-        <p:spPr>
-          <a:xfrm>
-            <a:off x="594360" y="2075688"/>
-            <a:ext cx="5577840" cy="457200"/>
-          </a:xfrm>
-          <a:prstGeom prst="rect">
-            <a:avLst/>
-          </a:prstGeom>
-          <a:noFill/>
-        </p:spPr>
-        <p:txBody>
-          <a:bodyPr wrap="square" lIns="0" rIns="0" tIns="0" bIns="0" anchor="t">
-            <a:spAutoFit/>
-          </a:bodyPr>
-          <a:lstStyle/>
-          <a:p>
-            <a:pPr algn="l">
-              <a:defRPr sz="2300" b="1">
-                <a:solidFill>
-                  <a:srgbClr val="69E3AC"/>
-                </a:solidFill>
-                <a:latin typeface="Aptos"/>
-              </a:defRPr>
-            </a:pPr>
-            <a:r>
-              <a:t>Zero-Trust Prompt Injection Firewall</a:t>
-            </a:r>
-          </a:p>
-        </p:txBody>
-      </p:sp>
-      <p:sp>
-        <p:nvSpPr>
-          <p:cNvPr id="9" name="TextBox 8"/>
-          <p:cNvSpPr txBox="1"/>
-          <p:nvPr/>
-        </p:nvSpPr>
-        <p:spPr>
-          <a:xfrm>
-            <a:off x="594360" y="2761488"/>
-            <a:ext cx="4937760" cy="347472"/>
-          </a:xfrm>
-          <a:prstGeom prst="rect">
-            <a:avLst/>
-          </a:prstGeom>
-          <a:noFill/>
-        </p:spPr>
-        <p:txBody>
-          <a:bodyPr wrap="square" lIns="0" rIns="0" tIns="0" bIns="0" anchor="t">
-            <a:spAutoFit/>
-          </a:bodyPr>
-          <a:lstStyle/>
-          <a:p>
-            <a:pPr algn="l">
-              <a:defRPr sz="1900" b="0">
-                <a:solidFill>
-                  <a:srgbClr val="EDF5F1"/>
-                </a:solidFill>
-                <a:latin typeface="Aptos"/>
-              </a:defRPr>
-            </a:pPr>
-            <a:r>
-              <a:t>Inspect before the agent can act.</a:t>
-            </a:r>
-          </a:p>
-        </p:txBody>
-      </p:sp>
-      <p:sp>
-        <p:nvSpPr>
-          <p:cNvPr id="10" name="Rounded Rectangle 9"/>
-          <p:cNvSpPr/>
-          <p:nvPr/>
-        </p:nvSpPr>
-        <p:spPr>
-          <a:xfrm>
-            <a:off x="594360" y="3410712"/>
+            <a:off x="594360" y="3502152"/>
             <a:ext cx="1600200" cy="310896"/>
           </a:xfrm>
           <a:prstGeom prst="roundRect">
@@ -3436,13 +3405,13 @@
       </p:sp>
       <p:sp>
         <p:nvSpPr>
-          <p:cNvPr id="11" name="TextBox 10"/>
-          <p:cNvSpPr txBox="1"/>
-          <p:nvPr/>
-        </p:nvSpPr>
-        <p:spPr>
-          <a:xfrm>
-            <a:off x="594360" y="3483864"/>
+          <p:cNvPr id="10" name="TextBox 9"/>
+          <p:cNvSpPr txBox="1"/>
+          <p:nvPr/>
+        </p:nvSpPr>
+        <p:spPr>
+          <a:xfrm>
+            <a:off x="594360" y="3575304"/>
             <a:ext cx="1600200" cy="137160"/>
           </a:xfrm>
           <a:prstGeom prst="rect">
@@ -3472,13 +3441,13 @@
       </p:sp>
       <p:sp>
         <p:nvSpPr>
-          <p:cNvPr id="12" name="Rounded Rectangle 11"/>
+          <p:cNvPr id="11" name="Rounded Rectangle 10"/>
           <p:cNvSpPr/>
           <p:nvPr/>
         </p:nvSpPr>
         <p:spPr>
           <a:xfrm>
-            <a:off x="2359152" y="3410712"/>
+            <a:off x="2359152" y="3502152"/>
             <a:ext cx="1508760" cy="310896"/>
           </a:xfrm>
           <a:prstGeom prst="roundRect">
@@ -3517,13 +3486,13 @@
       </p:sp>
       <p:sp>
         <p:nvSpPr>
-          <p:cNvPr id="13" name="TextBox 12"/>
-          <p:cNvSpPr txBox="1"/>
-          <p:nvPr/>
-        </p:nvSpPr>
-        <p:spPr>
-          <a:xfrm>
-            <a:off x="2359152" y="3483864"/>
+          <p:cNvPr id="12" name="TextBox 11"/>
+          <p:cNvSpPr txBox="1"/>
+          <p:nvPr/>
+        </p:nvSpPr>
+        <p:spPr>
+          <a:xfrm>
+            <a:off x="2359152" y="3575304"/>
             <a:ext cx="1508760" cy="137160"/>
           </a:xfrm>
           <a:prstGeom prst="rect">
@@ -3553,13 +3522,13 @@
       </p:sp>
       <p:sp>
         <p:nvSpPr>
-          <p:cNvPr id="14" name="Rounded Rectangle 13"/>
+          <p:cNvPr id="13" name="Rounded Rectangle 12"/>
           <p:cNvSpPr/>
           <p:nvPr/>
         </p:nvSpPr>
         <p:spPr>
           <a:xfrm>
-            <a:off x="4032504" y="3410712"/>
+            <a:off x="4032504" y="3502152"/>
             <a:ext cx="1234440" cy="310896"/>
           </a:xfrm>
           <a:prstGeom prst="roundRect">
@@ -3598,13 +3567,13 @@
       </p:sp>
       <p:sp>
         <p:nvSpPr>
-          <p:cNvPr id="15" name="TextBox 14"/>
-          <p:cNvSpPr txBox="1"/>
-          <p:nvPr/>
-        </p:nvSpPr>
-        <p:spPr>
-          <a:xfrm>
-            <a:off x="4032504" y="3483864"/>
+          <p:cNvPr id="14" name="TextBox 13"/>
+          <p:cNvSpPr txBox="1"/>
+          <p:nvPr/>
+        </p:nvSpPr>
+        <p:spPr>
+          <a:xfrm>
+            <a:off x="4032504" y="3575304"/>
             <a:ext cx="1234440" cy="137160"/>
           </a:xfrm>
           <a:prstGeom prst="rect">
@@ -3634,14 +3603,248 @@
       </p:sp>
       <p:sp>
         <p:nvSpPr>
+          <p:cNvPr id="15" name="Rounded Rectangle 14"/>
+          <p:cNvSpPr/>
+          <p:nvPr/>
+        </p:nvSpPr>
+        <p:spPr>
+          <a:xfrm>
+            <a:off x="594360" y="4590288"/>
+            <a:ext cx="5349240" cy="1234440"/>
+          </a:xfrm>
+          <a:prstGeom prst="roundRect">
+            <a:avLst/>
+          </a:prstGeom>
+          <a:solidFill>
+            <a:srgbClr val="0D2229"/>
+          </a:solidFill>
+          <a:ln w="12700">
+            <a:solidFill>
+              <a:srgbClr val="264149"/>
+            </a:solidFill>
+          </a:ln>
+        </p:spPr>
+        <p:style>
+          <a:lnRef idx="1">
+            <a:schemeClr val="accent1"/>
+          </a:lnRef>
+          <a:fillRef idx="3">
+            <a:schemeClr val="accent1"/>
+          </a:fillRef>
+          <a:effectRef idx="2">
+            <a:schemeClr val="accent1"/>
+          </a:effectRef>
+          <a:fontRef idx="minor">
+            <a:schemeClr val="lt1"/>
+          </a:fontRef>
+        </p:style>
+        <p:txBody>
+          <a:bodyPr rtlCol="0" anchor="ctr"/>
+          <a:lstStyle/>
+          <a:p>
+            <a:pPr algn="ctr"/>
+          </a:p>
+        </p:txBody>
+      </p:sp>
+      <p:sp>
+        <p:nvSpPr>
           <p:cNvPr id="16" name="TextBox 15"/>
           <p:cNvSpPr txBox="1"/>
           <p:nvPr/>
         </p:nvSpPr>
         <p:spPr>
           <a:xfrm>
-            <a:off x="594360" y="5212080"/>
-            <a:ext cx="4937760" cy="320040"/>
+            <a:off x="822960" y="4800600"/>
+            <a:ext cx="1280160" cy="164592"/>
+          </a:xfrm>
+          <a:prstGeom prst="rect">
+            <a:avLst/>
+          </a:prstGeom>
+          <a:noFill/>
+        </p:spPr>
+        <p:txBody>
+          <a:bodyPr wrap="square" lIns="0" rIns="0" tIns="0" bIns="0" anchor="t">
+            <a:spAutoFit/>
+          </a:bodyPr>
+          <a:lstStyle/>
+          <a:p>
+            <a:pPr algn="l">
+              <a:defRPr sz="900" b="1">
+                <a:solidFill>
+                  <a:srgbClr val="69E3AC"/>
+                </a:solidFill>
+                <a:latin typeface="Cascadia Mono"/>
+              </a:defRPr>
+            </a:pPr>
+            <a:r>
+              <a:t>SOLO TEAM</a:t>
+            </a:r>
+          </a:p>
+        </p:txBody>
+      </p:sp>
+      <p:sp>
+        <p:nvSpPr>
+          <p:cNvPr id="17" name="TextBox 16"/>
+          <p:cNvSpPr txBox="1"/>
+          <p:nvPr/>
+        </p:nvSpPr>
+        <p:spPr>
+          <a:xfrm>
+            <a:off x="822960" y="5102352"/>
+            <a:ext cx="3383280" cy="274320"/>
+          </a:xfrm>
+          <a:prstGeom prst="rect">
+            <a:avLst/>
+          </a:prstGeom>
+          <a:noFill/>
+        </p:spPr>
+        <p:txBody>
+          <a:bodyPr wrap="square" lIns="0" rIns="0" tIns="0" bIns="0" anchor="t">
+            <a:spAutoFit/>
+          </a:bodyPr>
+          <a:lstStyle/>
+          <a:p>
+            <a:pPr algn="l">
+              <a:defRPr sz="1800" b="1">
+                <a:solidFill>
+                  <a:srgbClr val="EDF5F1"/>
+                </a:solidFill>
+                <a:latin typeface="Cascadia Mono"/>
+              </a:defRPr>
+            </a:pPr>
+            <a:r>
+              <a:t>VISHWAJEET KUMAR</a:t>
+            </a:r>
+          </a:p>
+        </p:txBody>
+      </p:sp>
+      <p:sp>
+        <p:nvSpPr>
+          <p:cNvPr id="18" name="TextBox 17"/>
+          <p:cNvSpPr txBox="1"/>
+          <p:nvPr/>
+        </p:nvSpPr>
+        <p:spPr>
+          <a:xfrm>
+            <a:off x="822960" y="5468112"/>
+            <a:ext cx="4480560" cy="210312"/>
+          </a:xfrm>
+          <a:prstGeom prst="rect">
+            <a:avLst/>
+          </a:prstGeom>
+          <a:noFill/>
+        </p:spPr>
+        <p:txBody>
+          <a:bodyPr wrap="square" lIns="0" rIns="0" tIns="0" bIns="0" anchor="t">
+            <a:spAutoFit/>
+          </a:bodyPr>
+          <a:lstStyle/>
+          <a:p>
+            <a:pPr algn="l">
+              <a:defRPr sz="1300" b="0">
+                <a:solidFill>
+                  <a:srgbClr val="8CA39F"/>
+                </a:solidFill>
+                <a:latin typeface="Aptos"/>
+              </a:defRPr>
+            </a:pPr>
+            <a:r>
+              <a:t>Builder · AI security engineer · Presenter</a:t>
+            </a:r>
+          </a:p>
+        </p:txBody>
+      </p:sp>
+      <p:sp>
+        <p:nvSpPr>
+          <p:cNvPr id="19" name="Rounded Rectangle 18"/>
+          <p:cNvSpPr/>
+          <p:nvPr/>
+        </p:nvSpPr>
+        <p:spPr>
+          <a:xfrm>
+            <a:off x="6446520" y="566928"/>
+            <a:ext cx="5138928" cy="5623560"/>
+          </a:xfrm>
+          <a:prstGeom prst="roundRect">
+            <a:avLst/>
+          </a:prstGeom>
+          <a:solidFill>
+            <a:srgbClr val="091A20"/>
+          </a:solidFill>
+          <a:ln w="12700">
+            <a:solidFill>
+              <a:srgbClr val="69E3AC"/>
+            </a:solidFill>
+          </a:ln>
+        </p:spPr>
+        <p:style>
+          <a:lnRef idx="1">
+            <a:schemeClr val="accent1"/>
+          </a:lnRef>
+          <a:fillRef idx="3">
+            <a:schemeClr val="accent1"/>
+          </a:fillRef>
+          <a:effectRef idx="2">
+            <a:schemeClr val="accent1"/>
+          </a:effectRef>
+          <a:fontRef idx="minor">
+            <a:schemeClr val="lt1"/>
+          </a:fontRef>
+        </p:style>
+        <p:txBody>
+          <a:bodyPr rtlCol="0" anchor="ctr"/>
+          <a:lstStyle/>
+          <a:p>
+            <a:pPr algn="ctr"/>
+          </a:p>
+        </p:txBody>
+      </p:sp>
+      <p:sp>
+        <p:nvSpPr>
+          <p:cNvPr id="20" name="TextBox 19"/>
+          <p:cNvSpPr txBox="1"/>
+          <p:nvPr/>
+        </p:nvSpPr>
+        <p:spPr>
+          <a:xfrm>
+            <a:off x="6784848" y="896112"/>
+            <a:ext cx="4114800" cy="201168"/>
+          </a:xfrm>
+          <a:prstGeom prst="rect">
+            <a:avLst/>
+          </a:prstGeom>
+          <a:noFill/>
+        </p:spPr>
+        <p:txBody>
+          <a:bodyPr wrap="square" lIns="0" rIns="0" tIns="0" bIns="0" anchor="t">
+            <a:spAutoFit/>
+          </a:bodyPr>
+          <a:lstStyle/>
+          <a:p>
+            <a:pPr algn="l">
+              <a:defRPr sz="1100" b="1">
+                <a:solidFill>
+                  <a:srgbClr val="69E3AC"/>
+                </a:solidFill>
+                <a:latin typeface="Cascadia Mono"/>
+              </a:defRPr>
+            </a:pPr>
+            <a:r>
+              <a:t>SOLUTION AT A GLANCE</a:t>
+            </a:r>
+          </a:p>
+        </p:txBody>
+      </p:sp>
+      <p:sp>
+        <p:nvSpPr>
+          <p:cNvPr id="21" name="TextBox 20"/>
+          <p:cNvSpPr txBox="1"/>
+          <p:nvPr/>
+        </p:nvSpPr>
+        <p:spPr>
+          <a:xfrm>
+            <a:off x="6784848" y="1243584"/>
+            <a:ext cx="4224528" cy="530352"/>
           </a:xfrm>
           <a:prstGeom prst="rect">
             <a:avLst/>
@@ -3659,39 +3862,156 @@
                 <a:solidFill>
                   <a:srgbClr val="EDF5F1"/>
                 </a:solidFill>
+                <a:latin typeface="Aptos"/>
+              </a:defRPr>
+            </a:pPr>
+            <a:r>
+              <a:t>Untrusted inputs become controlled data—not agent authority.</a:t>
+            </a:r>
+          </a:p>
+        </p:txBody>
+      </p:sp>
+      <p:sp>
+        <p:nvSpPr>
+          <p:cNvPr id="22" name="Rounded Rectangle 21"/>
+          <p:cNvSpPr/>
+          <p:nvPr/>
+        </p:nvSpPr>
+        <p:spPr>
+          <a:xfrm>
+            <a:off x="6839712" y="2057400"/>
+            <a:ext cx="4315968" cy="749808"/>
+          </a:xfrm>
+          <a:prstGeom prst="roundRect">
+            <a:avLst/>
+          </a:prstGeom>
+          <a:solidFill>
+            <a:srgbClr val="0D2229"/>
+          </a:solidFill>
+          <a:ln w="12700">
+            <a:solidFill>
+              <a:srgbClr val="FF747C"/>
+            </a:solidFill>
+          </a:ln>
+        </p:spPr>
+        <p:style>
+          <a:lnRef idx="1">
+            <a:schemeClr val="accent1"/>
+          </a:lnRef>
+          <a:fillRef idx="3">
+            <a:schemeClr val="accent1"/>
+          </a:fillRef>
+          <a:effectRef idx="2">
+            <a:schemeClr val="accent1"/>
+          </a:effectRef>
+          <a:fontRef idx="minor">
+            <a:schemeClr val="lt1"/>
+          </a:fontRef>
+        </p:style>
+        <p:txBody>
+          <a:bodyPr rtlCol="0" anchor="ctr"/>
+          <a:lstStyle/>
+          <a:p>
+            <a:pPr algn="ctr"/>
+          </a:p>
+        </p:txBody>
+      </p:sp>
+      <p:sp>
+        <p:nvSpPr>
+          <p:cNvPr id="23" name="TextBox 22"/>
+          <p:cNvSpPr txBox="1"/>
+          <p:nvPr/>
+        </p:nvSpPr>
+        <p:spPr>
+          <a:xfrm>
+            <a:off x="7022592" y="2221992"/>
+            <a:ext cx="320040" cy="164592"/>
+          </a:xfrm>
+          <a:prstGeom prst="rect">
+            <a:avLst/>
+          </a:prstGeom>
+          <a:noFill/>
+        </p:spPr>
+        <p:txBody>
+          <a:bodyPr wrap="square" lIns="0" rIns="0" tIns="0" bIns="0" anchor="t">
+            <a:spAutoFit/>
+          </a:bodyPr>
+          <a:lstStyle/>
+          <a:p>
+            <a:pPr algn="l">
+              <a:defRPr sz="900" b="1">
+                <a:solidFill>
+                  <a:srgbClr val="FF747C"/>
+                </a:solidFill>
                 <a:latin typeface="Cascadia Mono"/>
               </a:defRPr>
             </a:pPr>
             <a:r>
-              <a:t>VISHWAJEET KUMAR</a:t>
-            </a:r>
-          </a:p>
-        </p:txBody>
-      </p:sp>
-      <p:sp>
-        <p:nvSpPr>
-          <p:cNvPr id="17" name="TextBox 16"/>
-          <p:cNvSpPr txBox="1"/>
-          <p:nvPr/>
-        </p:nvSpPr>
-        <p:spPr>
-          <a:xfrm>
-            <a:off x="594360" y="5632704"/>
-            <a:ext cx="5029200" cy="274320"/>
-          </a:xfrm>
-          <a:prstGeom prst="rect">
-            <a:avLst/>
-          </a:prstGeom>
-          <a:noFill/>
-        </p:spPr>
-        <p:txBody>
-          <a:bodyPr wrap="square" lIns="0" rIns="0" tIns="0" bIns="0" anchor="t">
-            <a:spAutoFit/>
-          </a:bodyPr>
-          <a:lstStyle/>
-          <a:p>
-            <a:pPr algn="l">
-              <a:defRPr sz="1400" b="0">
+              <a:t>01</a:t>
+            </a:r>
+          </a:p>
+        </p:txBody>
+      </p:sp>
+      <p:sp>
+        <p:nvSpPr>
+          <p:cNvPr id="24" name="TextBox 23"/>
+          <p:cNvSpPr txBox="1"/>
+          <p:nvPr/>
+        </p:nvSpPr>
+        <p:spPr>
+          <a:xfrm>
+            <a:off x="7461504" y="2176272"/>
+            <a:ext cx="1828800" cy="182880"/>
+          </a:xfrm>
+          <a:prstGeom prst="rect">
+            <a:avLst/>
+          </a:prstGeom>
+          <a:noFill/>
+        </p:spPr>
+        <p:txBody>
+          <a:bodyPr wrap="square" lIns="0" rIns="0" tIns="0" bIns="0" anchor="t">
+            <a:spAutoFit/>
+          </a:bodyPr>
+          <a:lstStyle/>
+          <a:p>
+            <a:pPr algn="l">
+              <a:defRPr sz="1200" b="1">
+                <a:solidFill>
+                  <a:srgbClr val="EDF5F1"/>
+                </a:solidFill>
+                <a:latin typeface="Aptos"/>
+              </a:defRPr>
+            </a:pPr>
+            <a:r>
+              <a:t>UNTRUSTED CONTENT</a:t>
+            </a:r>
+          </a:p>
+        </p:txBody>
+      </p:sp>
+      <p:sp>
+        <p:nvSpPr>
+          <p:cNvPr id="25" name="TextBox 24"/>
+          <p:cNvSpPr txBox="1"/>
+          <p:nvPr/>
+        </p:nvSpPr>
+        <p:spPr>
+          <a:xfrm>
+            <a:off x="7461504" y="2441448"/>
+            <a:ext cx="3337560" cy="182880"/>
+          </a:xfrm>
+          <a:prstGeom prst="rect">
+            <a:avLst/>
+          </a:prstGeom>
+          <a:noFill/>
+        </p:spPr>
+        <p:txBody>
+          <a:bodyPr wrap="square" lIns="0" rIns="0" tIns="0" bIns="0" anchor="t">
+            <a:spAutoFit/>
+          </a:bodyPr>
+          <a:lstStyle/>
+          <a:p>
+            <a:pPr algn="l">
+              <a:defRPr sz="1000" b="0">
                 <a:solidFill>
                   <a:srgbClr val="8CA39F"/>
                 </a:solidFill>
@@ -3699,7 +4019,421 @@
               </a:defRPr>
             </a:pPr>
             <a:r>
-              <a:t>Working prototype + structural architecture</a:t>
+              <a:t>Chat · files · web · email</a:t>
+            </a:r>
+          </a:p>
+        </p:txBody>
+      </p:sp>
+      <p:sp>
+        <p:nvSpPr>
+          <p:cNvPr id="26" name="TextBox 25"/>
+          <p:cNvSpPr txBox="1"/>
+          <p:nvPr/>
+        </p:nvSpPr>
+        <p:spPr>
+          <a:xfrm>
+            <a:off x="8759952" y="2825496"/>
+            <a:ext cx="457200" cy="201168"/>
+          </a:xfrm>
+          <a:prstGeom prst="rect">
+            <a:avLst/>
+          </a:prstGeom>
+          <a:noFill/>
+        </p:spPr>
+        <p:txBody>
+          <a:bodyPr wrap="square" lIns="0" rIns="0" tIns="0" bIns="0" anchor="t">
+            <a:spAutoFit/>
+          </a:bodyPr>
+          <a:lstStyle/>
+          <a:p>
+            <a:pPr algn="ctr">
+              <a:defRPr sz="1600" b="1">
+                <a:solidFill>
+                  <a:srgbClr val="69E3AC"/>
+                </a:solidFill>
+                <a:latin typeface="Aptos"/>
+              </a:defRPr>
+            </a:pPr>
+            <a:r>
+              <a:t>↓</a:t>
+            </a:r>
+          </a:p>
+        </p:txBody>
+      </p:sp>
+      <p:sp>
+        <p:nvSpPr>
+          <p:cNvPr id="27" name="Rounded Rectangle 26"/>
+          <p:cNvSpPr/>
+          <p:nvPr/>
+        </p:nvSpPr>
+        <p:spPr>
+          <a:xfrm>
+            <a:off x="6839712" y="3090672"/>
+            <a:ext cx="4315968" cy="749808"/>
+          </a:xfrm>
+          <a:prstGeom prst="roundRect">
+            <a:avLst/>
+          </a:prstGeom>
+          <a:solidFill>
+            <a:srgbClr val="0D2229"/>
+          </a:solidFill>
+          <a:ln w="12700">
+            <a:solidFill>
+              <a:srgbClr val="69E3AC"/>
+            </a:solidFill>
+          </a:ln>
+        </p:spPr>
+        <p:style>
+          <a:lnRef idx="1">
+            <a:schemeClr val="accent1"/>
+          </a:lnRef>
+          <a:fillRef idx="3">
+            <a:schemeClr val="accent1"/>
+          </a:fillRef>
+          <a:effectRef idx="2">
+            <a:schemeClr val="accent1"/>
+          </a:effectRef>
+          <a:fontRef idx="minor">
+            <a:schemeClr val="lt1"/>
+          </a:fontRef>
+        </p:style>
+        <p:txBody>
+          <a:bodyPr rtlCol="0" anchor="ctr"/>
+          <a:lstStyle/>
+          <a:p>
+            <a:pPr algn="ctr"/>
+          </a:p>
+        </p:txBody>
+      </p:sp>
+      <p:sp>
+        <p:nvSpPr>
+          <p:cNvPr id="28" name="TextBox 27"/>
+          <p:cNvSpPr txBox="1"/>
+          <p:nvPr/>
+        </p:nvSpPr>
+        <p:spPr>
+          <a:xfrm>
+            <a:off x="7022592" y="3255264"/>
+            <a:ext cx="320040" cy="164592"/>
+          </a:xfrm>
+          <a:prstGeom prst="rect">
+            <a:avLst/>
+          </a:prstGeom>
+          <a:noFill/>
+        </p:spPr>
+        <p:txBody>
+          <a:bodyPr wrap="square" lIns="0" rIns="0" tIns="0" bIns="0" anchor="t">
+            <a:spAutoFit/>
+          </a:bodyPr>
+          <a:lstStyle/>
+          <a:p>
+            <a:pPr algn="l">
+              <a:defRPr sz="900" b="1">
+                <a:solidFill>
+                  <a:srgbClr val="69E3AC"/>
+                </a:solidFill>
+                <a:latin typeface="Cascadia Mono"/>
+              </a:defRPr>
+            </a:pPr>
+            <a:r>
+              <a:t>02</a:t>
+            </a:r>
+          </a:p>
+        </p:txBody>
+      </p:sp>
+      <p:sp>
+        <p:nvSpPr>
+          <p:cNvPr id="29" name="TextBox 28"/>
+          <p:cNvSpPr txBox="1"/>
+          <p:nvPr/>
+        </p:nvSpPr>
+        <p:spPr>
+          <a:xfrm>
+            <a:off x="7461504" y="3209544"/>
+            <a:ext cx="1828800" cy="182880"/>
+          </a:xfrm>
+          <a:prstGeom prst="rect">
+            <a:avLst/>
+          </a:prstGeom>
+          <a:noFill/>
+        </p:spPr>
+        <p:txBody>
+          <a:bodyPr wrap="square" lIns="0" rIns="0" tIns="0" bIns="0" anchor="t">
+            <a:spAutoFit/>
+          </a:bodyPr>
+          <a:lstStyle/>
+          <a:p>
+            <a:pPr algn="l">
+              <a:defRPr sz="1200" b="1">
+                <a:solidFill>
+                  <a:srgbClr val="EDF5F1"/>
+                </a:solidFill>
+                <a:latin typeface="Aptos"/>
+              </a:defRPr>
+            </a:pPr>
+            <a:r>
+              <a:t>SENTINELGATE</a:t>
+            </a:r>
+          </a:p>
+        </p:txBody>
+      </p:sp>
+      <p:sp>
+        <p:nvSpPr>
+          <p:cNvPr id="30" name="TextBox 29"/>
+          <p:cNvSpPr txBox="1"/>
+          <p:nvPr/>
+        </p:nvSpPr>
+        <p:spPr>
+          <a:xfrm>
+            <a:off x="7461504" y="3474720"/>
+            <a:ext cx="3337560" cy="182880"/>
+          </a:xfrm>
+          <a:prstGeom prst="rect">
+            <a:avLst/>
+          </a:prstGeom>
+          <a:noFill/>
+        </p:spPr>
+        <p:txBody>
+          <a:bodyPr wrap="square" lIns="0" rIns="0" tIns="0" bIns="0" anchor="t">
+            <a:spAutoFit/>
+          </a:bodyPr>
+          <a:lstStyle/>
+          <a:p>
+            <a:pPr algn="l">
+              <a:defRPr sz="1000" b="0">
+                <a:solidFill>
+                  <a:srgbClr val="8CA39F"/>
+                </a:solidFill>
+                <a:latin typeface="Aptos"/>
+              </a:defRPr>
+            </a:pPr>
+            <a:r>
+              <a:t>Inspect · decide · enforce</a:t>
+            </a:r>
+          </a:p>
+        </p:txBody>
+      </p:sp>
+      <p:sp>
+        <p:nvSpPr>
+          <p:cNvPr id="31" name="TextBox 30"/>
+          <p:cNvSpPr txBox="1"/>
+          <p:nvPr/>
+        </p:nvSpPr>
+        <p:spPr>
+          <a:xfrm>
+            <a:off x="8759952" y="3858768"/>
+            <a:ext cx="457200" cy="201168"/>
+          </a:xfrm>
+          <a:prstGeom prst="rect">
+            <a:avLst/>
+          </a:prstGeom>
+          <a:noFill/>
+        </p:spPr>
+        <p:txBody>
+          <a:bodyPr wrap="square" lIns="0" rIns="0" tIns="0" bIns="0" anchor="t">
+            <a:spAutoFit/>
+          </a:bodyPr>
+          <a:lstStyle/>
+          <a:p>
+            <a:pPr algn="ctr">
+              <a:defRPr sz="1600" b="1">
+                <a:solidFill>
+                  <a:srgbClr val="69E3AC"/>
+                </a:solidFill>
+                <a:latin typeface="Aptos"/>
+              </a:defRPr>
+            </a:pPr>
+            <a:r>
+              <a:t>↓</a:t>
+            </a:r>
+          </a:p>
+        </p:txBody>
+      </p:sp>
+      <p:sp>
+        <p:nvSpPr>
+          <p:cNvPr id="32" name="Rounded Rectangle 31"/>
+          <p:cNvSpPr/>
+          <p:nvPr/>
+        </p:nvSpPr>
+        <p:spPr>
+          <a:xfrm>
+            <a:off x="6839712" y="4123944"/>
+            <a:ext cx="4315968" cy="749808"/>
+          </a:xfrm>
+          <a:prstGeom prst="roundRect">
+            <a:avLst/>
+          </a:prstGeom>
+          <a:solidFill>
+            <a:srgbClr val="0D2229"/>
+          </a:solidFill>
+          <a:ln w="12700">
+            <a:solidFill>
+              <a:srgbClr val="6FB9FF"/>
+            </a:solidFill>
+          </a:ln>
+        </p:spPr>
+        <p:style>
+          <a:lnRef idx="1">
+            <a:schemeClr val="accent1"/>
+          </a:lnRef>
+          <a:fillRef idx="3">
+            <a:schemeClr val="accent1"/>
+          </a:fillRef>
+          <a:effectRef idx="2">
+            <a:schemeClr val="accent1"/>
+          </a:effectRef>
+          <a:fontRef idx="minor">
+            <a:schemeClr val="lt1"/>
+          </a:fontRef>
+        </p:style>
+        <p:txBody>
+          <a:bodyPr rtlCol="0" anchor="ctr"/>
+          <a:lstStyle/>
+          <a:p>
+            <a:pPr algn="ctr"/>
+          </a:p>
+        </p:txBody>
+      </p:sp>
+      <p:sp>
+        <p:nvSpPr>
+          <p:cNvPr id="33" name="TextBox 32"/>
+          <p:cNvSpPr txBox="1"/>
+          <p:nvPr/>
+        </p:nvSpPr>
+        <p:spPr>
+          <a:xfrm>
+            <a:off x="7022592" y="4288536"/>
+            <a:ext cx="320040" cy="164592"/>
+          </a:xfrm>
+          <a:prstGeom prst="rect">
+            <a:avLst/>
+          </a:prstGeom>
+          <a:noFill/>
+        </p:spPr>
+        <p:txBody>
+          <a:bodyPr wrap="square" lIns="0" rIns="0" tIns="0" bIns="0" anchor="t">
+            <a:spAutoFit/>
+          </a:bodyPr>
+          <a:lstStyle/>
+          <a:p>
+            <a:pPr algn="l">
+              <a:defRPr sz="900" b="1">
+                <a:solidFill>
+                  <a:srgbClr val="6FB9FF"/>
+                </a:solidFill>
+                <a:latin typeface="Cascadia Mono"/>
+              </a:defRPr>
+            </a:pPr>
+            <a:r>
+              <a:t>03</a:t>
+            </a:r>
+          </a:p>
+        </p:txBody>
+      </p:sp>
+      <p:sp>
+        <p:nvSpPr>
+          <p:cNvPr id="34" name="TextBox 33"/>
+          <p:cNvSpPr txBox="1"/>
+          <p:nvPr/>
+        </p:nvSpPr>
+        <p:spPr>
+          <a:xfrm>
+            <a:off x="7461504" y="4242816"/>
+            <a:ext cx="1828800" cy="182880"/>
+          </a:xfrm>
+          <a:prstGeom prst="rect">
+            <a:avLst/>
+          </a:prstGeom>
+          <a:noFill/>
+        </p:spPr>
+        <p:txBody>
+          <a:bodyPr wrap="square" lIns="0" rIns="0" tIns="0" bIns="0" anchor="t">
+            <a:spAutoFit/>
+          </a:bodyPr>
+          <a:lstStyle/>
+          <a:p>
+            <a:pPr algn="l">
+              <a:defRPr sz="1200" b="1">
+                <a:solidFill>
+                  <a:srgbClr val="EDF5F1"/>
+                </a:solidFill>
+                <a:latin typeface="Aptos"/>
+              </a:defRPr>
+            </a:pPr>
+            <a:r>
+              <a:t>PROTECTED AGENT</a:t>
+            </a:r>
+          </a:p>
+        </p:txBody>
+      </p:sp>
+      <p:sp>
+        <p:nvSpPr>
+          <p:cNvPr id="35" name="TextBox 34"/>
+          <p:cNvSpPr txBox="1"/>
+          <p:nvPr/>
+        </p:nvSpPr>
+        <p:spPr>
+          <a:xfrm>
+            <a:off x="7461504" y="4507992"/>
+            <a:ext cx="3337560" cy="182880"/>
+          </a:xfrm>
+          <a:prstGeom prst="rect">
+            <a:avLst/>
+          </a:prstGeom>
+          <a:noFill/>
+        </p:spPr>
+        <p:txBody>
+          <a:bodyPr wrap="square" lIns="0" rIns="0" tIns="0" bIns="0" anchor="t">
+            <a:spAutoFit/>
+          </a:bodyPr>
+          <a:lstStyle/>
+          <a:p>
+            <a:pPr algn="l">
+              <a:defRPr sz="1000" b="0">
+                <a:solidFill>
+                  <a:srgbClr val="8CA39F"/>
+                </a:solidFill>
+                <a:latin typeface="Aptos"/>
+              </a:defRPr>
+            </a:pPr>
+            <a:r>
+              <a:t>Signed data · least privilege</a:t>
+            </a:r>
+          </a:p>
+        </p:txBody>
+      </p:sp>
+      <p:sp>
+        <p:nvSpPr>
+          <p:cNvPr id="36" name="TextBox 35"/>
+          <p:cNvSpPr txBox="1"/>
+          <p:nvPr/>
+        </p:nvSpPr>
+        <p:spPr>
+          <a:xfrm>
+            <a:off x="6784848" y="5715000"/>
+            <a:ext cx="4370832" cy="201168"/>
+          </a:xfrm>
+          <a:prstGeom prst="rect">
+            <a:avLst/>
+          </a:prstGeom>
+          <a:noFill/>
+        </p:spPr>
+        <p:txBody>
+          <a:bodyPr wrap="square" lIns="0" rIns="0" tIns="0" bIns="0" anchor="t">
+            <a:spAutoFit/>
+          </a:bodyPr>
+          <a:lstStyle/>
+          <a:p>
+            <a:pPr algn="ctr">
+              <a:defRPr sz="900" b="1">
+                <a:solidFill>
+                  <a:srgbClr val="F2BD63"/>
+                </a:solidFill>
+                <a:latin typeface="Cascadia Mono"/>
+              </a:defRPr>
+            </a:pPr>
+            <a:r>
+              <a:t>WORKING PROTOTYPE  ·  LIVE QUARANTINE  ·  AUDITABLE</a:t>
             </a:r>
           </a:p>
         </p:txBody>
@@ -5076,7 +5810,7 @@
               </a:defRPr>
             </a:pPr>
             <a:r>
-              <a:t>IMPACT AND SCALABILITY</a:t>
+              <a:t>BUSINESS IMPACT</a:t>
             </a:r>
           </a:p>
         </p:txBody>
@@ -5112,7 +5846,7 @@
               </a:defRPr>
             </a:pPr>
             <a:r>
-              <a:t>From hackathon prototype to enterprise security plane</a:t>
+              <a:t>Business impact, scalability, and future roadmap</a:t>
             </a:r>
           </a:p>
         </p:txBody>
@@ -7524,7 +8258,7 @@
               </a:defRPr>
             </a:pPr>
             <a:r>
-              <a:t>THE CHALLENGE</a:t>
+              <a:t>PROBLEM STATEMENT</a:t>
             </a:r>
           </a:p>
         </p:txBody>
@@ -8316,7 +9050,7 @@
               </a:defRPr>
             </a:pPr>
             <a:r>
-              <a:t>THE SOLUTION</a:t>
+              <a:t>PROPOSED SOLUTION</a:t>
             </a:r>
           </a:p>
         </p:txBody>
@@ -11625,7 +12359,7 @@
               </a:defRPr>
             </a:pPr>
             <a:r>
-              <a:t>STRUCTURAL ARCHITECTURE</a:t>
+              <a:t>ARCHITECTURE</a:t>
             </a:r>
           </a:p>
         </p:txBody>
@@ -13770,7 +14504,7 @@
               </a:defRPr>
             </a:pPr>
             <a:r>
-              <a:t>WORKING PROTOTYPE</a:t>
+              <a:t>PRODUCT DEMO</a:t>
             </a:r>
           </a:p>
         </p:txBody>
@@ -14779,7 +15513,7 @@
               </a:defRPr>
             </a:pPr>
             <a:r>
-              <a:t>LIVE ENTERPRISE DEFENSE</a:t>
+              <a:t>PRODUCT DEMO</a:t>
             </a:r>
           </a:p>
         </p:txBody>
@@ -15895,7 +16629,7 @@
               </a:defRPr>
             </a:pPr>
             <a:r>
-              <a:t>AGENTIC CAPABILITY</a:t>
+              <a:t>AI MODELS &amp; TECHNOLOGIES USED</a:t>
             </a:r>
           </a:p>
         </p:txBody>
@@ -15931,7 +16665,7 @@
               </a:defRPr>
             </a:pPr>
             <a:r>
-              <a:t>Stateful intent defense and action governance</a:t>
+              <a:t>Transparent hybrid detection with agentic controls</a:t>
             </a:r>
           </a:p>
         </p:txBody>
@@ -16023,8 +16757,8 @@
         </p:nvSpPr>
         <p:spPr>
           <a:xfrm>
-            <a:off x="576072" y="1792224"/>
-            <a:ext cx="6025896" cy="3401568"/>
+            <a:off x="576072" y="1810512"/>
+            <a:ext cx="5065776" cy="2871216"/>
           </a:xfrm>
           <a:prstGeom prst="roundRect">
             <a:avLst/>
@@ -16076,8 +16810,8 @@
         </p:blipFill>
         <p:spPr>
           <a:xfrm>
-            <a:off x="594360" y="1810512"/>
-            <a:ext cx="5989320" cy="3364992"/>
+            <a:off x="594360" y="1828800"/>
+            <a:ext cx="5029200" cy="2834640"/>
           </a:xfrm>
           <a:prstGeom prst="rect">
             <a:avLst/>
@@ -16092,8 +16826,8 @@
         </p:nvSpPr>
         <p:spPr>
           <a:xfrm>
-            <a:off x="6903720" y="1847088"/>
-            <a:ext cx="4572000" cy="868680"/>
+            <a:off x="5925312" y="1828800"/>
+            <a:ext cx="2679192" cy="1143000"/>
           </a:xfrm>
           <a:prstGeom prst="roundRect">
             <a:avLst/>
@@ -16137,8 +16871,8 @@
         </p:nvSpPr>
         <p:spPr>
           <a:xfrm>
-            <a:off x="7114032" y="1993392"/>
-            <a:ext cx="1572768" cy="164592"/>
+            <a:off x="6089904" y="1975104"/>
+            <a:ext cx="2331720" cy="182880"/>
           </a:xfrm>
           <a:prstGeom prst="rect">
             <a:avLst/>
@@ -16160,7 +16894,7 @@
               </a:defRPr>
             </a:pPr>
             <a:r>
-              <a:t>INTENT ANCHOR</a:t>
+              <a:t>DETECTION MODELS</a:t>
             </a:r>
           </a:p>
         </p:txBody>
@@ -16173,22 +16907,22 @@
         </p:nvSpPr>
         <p:spPr>
           <a:xfrm>
-            <a:off x="8503920" y="1965960"/>
-            <a:ext cx="2724912" cy="438912"/>
-          </a:xfrm>
-          <a:prstGeom prst="rect">
-            <a:avLst/>
-          </a:prstGeom>
-          <a:noFill/>
-        </p:spPr>
-        <p:txBody>
-          <a:bodyPr wrap="square" lIns="0" rIns="0" tIns="0" bIns="0" anchor="t">
-            <a:spAutoFit/>
-          </a:bodyPr>
-          <a:lstStyle/>
-          <a:p>
-            <a:pPr algn="l">
-              <a:defRPr sz="1200" b="0">
+            <a:off x="6089904" y="2267712"/>
+            <a:ext cx="2322576" cy="530352"/>
+          </a:xfrm>
+          <a:prstGeom prst="rect">
+            <a:avLst/>
+          </a:prstGeom>
+          <a:noFill/>
+        </p:spPr>
+        <p:txBody>
+          <a:bodyPr wrap="square" lIns="0" rIns="0" tIns="0" bIns="0" anchor="t">
+            <a:spAutoFit/>
+          </a:bodyPr>
+          <a:lstStyle/>
+          <a:p>
+            <a:pPr algn="l">
+              <a:defRPr sz="1100" b="0">
                 <a:solidFill>
                   <a:srgbClr val="EDF5F1"/>
                 </a:solidFill>
@@ -16196,7 +16930,7 @@
               </a:defRPr>
             </a:pPr>
             <a:r>
-              <a:t>Locks the declared objective and detects drift across turns.</a:t>
+              <a:t>Deterministic security rules + transparent TF-IDF/cosine semantic baseline.</a:t>
             </a:r>
           </a:p>
         </p:txBody>
@@ -16209,8 +16943,8 @@
         </p:nvSpPr>
         <p:spPr>
           <a:xfrm>
-            <a:off x="6903720" y="2962656"/>
-            <a:ext cx="4572000" cy="868680"/>
+            <a:off x="8796528" y="1828800"/>
+            <a:ext cx="2679192" cy="1143000"/>
           </a:xfrm>
           <a:prstGeom prst="roundRect">
             <a:avLst/>
@@ -16254,8 +16988,8 @@
         </p:nvSpPr>
         <p:spPr>
           <a:xfrm>
-            <a:off x="7114032" y="3108960"/>
-            <a:ext cx="1572768" cy="164592"/>
+            <a:off x="8961120" y="1975104"/>
+            <a:ext cx="2331720" cy="182880"/>
           </a:xfrm>
           <a:prstGeom prst="rect">
             <a:avLst/>
@@ -16277,7 +17011,7 @@
               </a:defRPr>
             </a:pPr>
             <a:r>
-              <a:t>TOOL POLICY</a:t>
+              <a:t>CONTENT INTELLIGENCE</a:t>
             </a:r>
           </a:p>
         </p:txBody>
@@ -16290,22 +17024,22 @@
         </p:nvSpPr>
         <p:spPr>
           <a:xfrm>
-            <a:off x="8503920" y="3081528"/>
-            <a:ext cx="2724912" cy="438912"/>
-          </a:xfrm>
-          <a:prstGeom prst="rect">
-            <a:avLst/>
-          </a:prstGeom>
-          <a:noFill/>
-        </p:spPr>
-        <p:txBody>
-          <a:bodyPr wrap="square" lIns="0" rIns="0" tIns="0" bIns="0" anchor="t">
-            <a:spAutoFit/>
-          </a:bodyPr>
-          <a:lstStyle/>
-          <a:p>
-            <a:pPr algn="l">
-              <a:defRPr sz="1200" b="0">
+            <a:off x="8961120" y="2267712"/>
+            <a:ext cx="2322576" cy="530352"/>
+          </a:xfrm>
+          <a:prstGeom prst="rect">
+            <a:avLst/>
+          </a:prstGeom>
+          <a:noFill/>
+        </p:spPr>
+        <p:txBody>
+          <a:bodyPr wrap="square" lIns="0" rIns="0" tIns="0" bIns="0" anchor="t">
+            <a:spAutoFit/>
+          </a:bodyPr>
+          <a:lstStyle/>
+          <a:p>
+            <a:pPr algn="l">
+              <a:defRPr sz="1100" b="0">
                 <a:solidFill>
                   <a:srgbClr val="EDF5F1"/>
                 </a:solidFill>
@@ -16313,7 +17047,7 @@
               </a:defRPr>
             </a:pPr>
             <a:r>
-              <a:t>Validates authorization, allowlist, schema, destination, and payload.</a:t>
+              <a:t>Recursive Base64/hex decoding; HTML, PDF, DOCX, EML and OCR adapters.</a:t>
             </a:r>
           </a:p>
         </p:txBody>
@@ -16326,8 +17060,8 @@
         </p:nvSpPr>
         <p:spPr>
           <a:xfrm>
-            <a:off x="6903720" y="4078224"/>
-            <a:ext cx="4572000" cy="868680"/>
+            <a:off x="5925312" y="3246120"/>
+            <a:ext cx="2679192" cy="1143000"/>
           </a:xfrm>
           <a:prstGeom prst="roundRect">
             <a:avLst/>
@@ -16371,8 +17105,8 @@
         </p:nvSpPr>
         <p:spPr>
           <a:xfrm>
-            <a:off x="7114032" y="4224528"/>
-            <a:ext cx="1572768" cy="164592"/>
+            <a:off x="6089904" y="3392424"/>
+            <a:ext cx="2331720" cy="182880"/>
           </a:xfrm>
           <a:prstGeom prst="rect">
             <a:avLst/>
@@ -16394,7 +17128,7 @@
               </a:defRPr>
             </a:pPr>
             <a:r>
-              <a:t>HUMAN OVERSIGHT</a:t>
+              <a:t>AGENTIC CONTROLS</a:t>
             </a:r>
           </a:p>
         </p:txBody>
@@ -16407,22 +17141,22 @@
         </p:nvSpPr>
         <p:spPr>
           <a:xfrm>
-            <a:off x="8503920" y="4197096"/>
-            <a:ext cx="2724912" cy="438912"/>
-          </a:xfrm>
-          <a:prstGeom prst="rect">
-            <a:avLst/>
-          </a:prstGeom>
-          <a:noFill/>
-        </p:spPr>
-        <p:txBody>
-          <a:bodyPr wrap="square" lIns="0" rIns="0" tIns="0" bIns="0" anchor="t">
-            <a:spAutoFit/>
-          </a:bodyPr>
-          <a:lstStyle/>
-          <a:p>
-            <a:pPr algn="l">
-              <a:defRPr sz="1200" b="0">
+            <a:off x="6089904" y="3685031"/>
+            <a:ext cx="2322576" cy="530352"/>
+          </a:xfrm>
+          <a:prstGeom prst="rect">
+            <a:avLst/>
+          </a:prstGeom>
+          <a:noFill/>
+        </p:spPr>
+        <p:txBody>
+          <a:bodyPr wrap="square" lIns="0" rIns="0" tIns="0" bIns="0" anchor="t">
+            <a:spAutoFit/>
+          </a:bodyPr>
+          <a:lstStyle/>
+          <a:p>
+            <a:pPr algn="l">
+              <a:defRPr sz="1100" b="0">
                 <a:solidFill>
                   <a:srgbClr val="EDF5F1"/>
                 </a:solidFill>
@@ -16430,21 +17164,255 @@
               </a:defRPr>
             </a:pPr>
             <a:r>
-              <a:t>High-risk actions stay disabled until explicit confirmation.</a:t>
-            </a:r>
-          </a:p>
-        </p:txBody>
-      </p:sp>
-      <p:sp>
-        <p:nvSpPr>
-          <p:cNvPr id="20" name="TextBox 19"/>
-          <p:cNvSpPr txBox="1"/>
-          <p:nvPr/>
-        </p:nvSpPr>
-        <p:spPr>
-          <a:xfrm>
-            <a:off x="594360" y="5559552"/>
-            <a:ext cx="10881360" cy="320040"/>
+              <a:t>Intent anchors, session-state risk, tool policy, confirmation and output guard.</a:t>
+            </a:r>
+          </a:p>
+        </p:txBody>
+      </p:sp>
+      <p:sp>
+        <p:nvSpPr>
+          <p:cNvPr id="20" name="Rounded Rectangle 19"/>
+          <p:cNvSpPr/>
+          <p:nvPr/>
+        </p:nvSpPr>
+        <p:spPr>
+          <a:xfrm>
+            <a:off x="8796528" y="3246120"/>
+            <a:ext cx="2679192" cy="1143000"/>
+          </a:xfrm>
+          <a:prstGeom prst="roundRect">
+            <a:avLst/>
+          </a:prstGeom>
+          <a:solidFill>
+            <a:srgbClr val="0D2229"/>
+          </a:solidFill>
+          <a:ln w="12700">
+            <a:solidFill>
+              <a:srgbClr val="69E3AC"/>
+            </a:solidFill>
+          </a:ln>
+        </p:spPr>
+        <p:style>
+          <a:lnRef idx="1">
+            <a:schemeClr val="accent1"/>
+          </a:lnRef>
+          <a:fillRef idx="3">
+            <a:schemeClr val="accent1"/>
+          </a:fillRef>
+          <a:effectRef idx="2">
+            <a:schemeClr val="accent1"/>
+          </a:effectRef>
+          <a:fontRef idx="minor">
+            <a:schemeClr val="lt1"/>
+          </a:fontRef>
+        </p:style>
+        <p:txBody>
+          <a:bodyPr rtlCol="0" anchor="ctr"/>
+          <a:lstStyle/>
+          <a:p>
+            <a:pPr algn="ctr"/>
+          </a:p>
+        </p:txBody>
+      </p:sp>
+      <p:sp>
+        <p:nvSpPr>
+          <p:cNvPr id="21" name="TextBox 20"/>
+          <p:cNvSpPr txBox="1"/>
+          <p:nvPr/>
+        </p:nvSpPr>
+        <p:spPr>
+          <a:xfrm>
+            <a:off x="8961120" y="3392424"/>
+            <a:ext cx="2331720" cy="182880"/>
+          </a:xfrm>
+          <a:prstGeom prst="rect">
+            <a:avLst/>
+          </a:prstGeom>
+          <a:noFill/>
+        </p:spPr>
+        <p:txBody>
+          <a:bodyPr wrap="square" lIns="0" rIns="0" tIns="0" bIns="0" anchor="t">
+            <a:spAutoFit/>
+          </a:bodyPr>
+          <a:lstStyle/>
+          <a:p>
+            <a:pPr algn="l">
+              <a:defRPr sz="900" b="1">
+                <a:solidFill>
+                  <a:srgbClr val="69E3AC"/>
+                </a:solidFill>
+                <a:latin typeface="Cascadia Mono"/>
+              </a:defRPr>
+            </a:pPr>
+            <a:r>
+              <a:t>PLATFORM &amp; TRUST</a:t>
+            </a:r>
+          </a:p>
+        </p:txBody>
+      </p:sp>
+      <p:sp>
+        <p:nvSpPr>
+          <p:cNvPr id="22" name="TextBox 21"/>
+          <p:cNvSpPr txBox="1"/>
+          <p:nvPr/>
+        </p:nvSpPr>
+        <p:spPr>
+          <a:xfrm>
+            <a:off x="8961120" y="3685031"/>
+            <a:ext cx="2322576" cy="530352"/>
+          </a:xfrm>
+          <a:prstGeom prst="rect">
+            <a:avLst/>
+          </a:prstGeom>
+          <a:noFill/>
+        </p:spPr>
+        <p:txBody>
+          <a:bodyPr wrap="square" lIns="0" rIns="0" tIns="0" bIns="0" anchor="t">
+            <a:spAutoFit/>
+          </a:bodyPr>
+          <a:lstStyle/>
+          <a:p>
+            <a:pPr algn="l">
+              <a:defRPr sz="1100" b="0">
+                <a:solidFill>
+                  <a:srgbClr val="EDF5F1"/>
+                </a:solidFill>
+                <a:latin typeface="Aptos"/>
+              </a:defRPr>
+            </a:pPr>
+            <a:r>
+              <a:t>Python · Flask · Redis/SQLite · HMAC-SHA256 · hash-chained audit.</a:t>
+            </a:r>
+          </a:p>
+        </p:txBody>
+      </p:sp>
+      <p:sp>
+        <p:nvSpPr>
+          <p:cNvPr id="23" name="Rounded Rectangle 22"/>
+          <p:cNvSpPr/>
+          <p:nvPr/>
+        </p:nvSpPr>
+        <p:spPr>
+          <a:xfrm>
+            <a:off x="594360" y="5010912"/>
+            <a:ext cx="10881360" cy="749808"/>
+          </a:xfrm>
+          <a:prstGeom prst="roundRect">
+            <a:avLst/>
+          </a:prstGeom>
+          <a:solidFill>
+            <a:srgbClr val="091A20"/>
+          </a:solidFill>
+          <a:ln w="12700">
+            <a:solidFill>
+              <a:srgbClr val="264149"/>
+            </a:solidFill>
+          </a:ln>
+        </p:spPr>
+        <p:style>
+          <a:lnRef idx="1">
+            <a:schemeClr val="accent1"/>
+          </a:lnRef>
+          <a:fillRef idx="3">
+            <a:schemeClr val="accent1"/>
+          </a:fillRef>
+          <a:effectRef idx="2">
+            <a:schemeClr val="accent1"/>
+          </a:effectRef>
+          <a:fontRef idx="minor">
+            <a:schemeClr val="lt1"/>
+          </a:fontRef>
+        </p:style>
+        <p:txBody>
+          <a:bodyPr rtlCol="0" anchor="ctr"/>
+          <a:lstStyle/>
+          <a:p>
+            <a:pPr algn="ctr"/>
+          </a:p>
+        </p:txBody>
+      </p:sp>
+      <p:sp>
+        <p:nvSpPr>
+          <p:cNvPr id="24" name="TextBox 23"/>
+          <p:cNvSpPr txBox="1"/>
+          <p:nvPr/>
+        </p:nvSpPr>
+        <p:spPr>
+          <a:xfrm>
+            <a:off x="804672" y="5230368"/>
+            <a:ext cx="1463040" cy="164592"/>
+          </a:xfrm>
+          <a:prstGeom prst="rect">
+            <a:avLst/>
+          </a:prstGeom>
+          <a:noFill/>
+        </p:spPr>
+        <p:txBody>
+          <a:bodyPr wrap="square" lIns="0" rIns="0" tIns="0" bIns="0" anchor="t">
+            <a:spAutoFit/>
+          </a:bodyPr>
+          <a:lstStyle/>
+          <a:p>
+            <a:pPr algn="l">
+              <a:defRPr sz="900" b="1">
+                <a:solidFill>
+                  <a:srgbClr val="69E3AC"/>
+                </a:solidFill>
+                <a:latin typeface="Cascadia Mono"/>
+              </a:defRPr>
+            </a:pPr>
+            <a:r>
+              <a:t>MODEL STRATEGY</a:t>
+            </a:r>
+          </a:p>
+        </p:txBody>
+      </p:sp>
+      <p:sp>
+        <p:nvSpPr>
+          <p:cNvPr id="25" name="TextBox 24"/>
+          <p:cNvSpPr txBox="1"/>
+          <p:nvPr/>
+        </p:nvSpPr>
+        <p:spPr>
+          <a:xfrm>
+            <a:off x="2331720" y="5175504"/>
+            <a:ext cx="8732520" cy="310896"/>
+          </a:xfrm>
+          <a:prstGeom prst="rect">
+            <a:avLst/>
+          </a:prstGeom>
+          <a:noFill/>
+        </p:spPr>
+        <p:txBody>
+          <a:bodyPr wrap="square" lIns="0" rIns="0" tIns="0" bIns="0" anchor="t">
+            <a:spAutoFit/>
+          </a:bodyPr>
+          <a:lstStyle/>
+          <a:p>
+            <a:pPr algn="l">
+              <a:defRPr sz="1300" b="1">
+                <a:solidFill>
+                  <a:srgbClr val="EDF5F1"/>
+                </a:solidFill>
+                <a:latin typeface="Aptos"/>
+              </a:defRPr>
+            </a:pPr>
+            <a:r>
+              <a:t>Model-agnostic enforcement: no cloud LLM dependency. Production roadmap adds ONNX embeddings and adversarial retraining.</a:t>
+            </a:r>
+          </a:p>
+        </p:txBody>
+      </p:sp>
+      <p:sp>
+        <p:nvSpPr>
+          <p:cNvPr id="26" name="TextBox 25"/>
+          <p:cNvSpPr txBox="1"/>
+          <p:nvPr/>
+        </p:nvSpPr>
+        <p:spPr>
+          <a:xfrm>
+            <a:off x="594360" y="5989320"/>
+            <a:ext cx="10881360" cy="256032"/>
           </a:xfrm>
           <a:prstGeom prst="rect">
             <a:avLst/>
@@ -16458,7 +17426,7 @@
           <a:lstStyle/>
           <a:p>
             <a:pPr algn="ctr">
-              <a:defRPr sz="1800" b="1">
+              <a:defRPr sz="1600" b="1">
                 <a:solidFill>
                   <a:srgbClr val="69E3AC"/>
                 </a:solidFill>

</xml_diff>